<commit_message>
Deck: the typecheck is clean now, and the APM gap is closed
Two figures went stale when the APM view was rebuilt on /v1/platform:

  "Dashboard typecheck: 1 error, in dead code"  ->  clean
        PerformanceView.tsx was the only error. It imported a mock data module
        that had never been committed, and it is gone.

  Next slide                                    ->  the APM item is done
        The tab renders, so "remove the APM tab ... but renders nothing" now
        describes nothing.

The replacement Next item states a checked number rather than a remembered one.
The dashboard has 33 components and 32 tests, and all 32 sit on adapters.ts and
api.ts -- no component has one. A draft of this line said "nineteen", carried
over from an older note; counting the files said 33.

Co-Authored-By: Claude Opus 5 <noreply@anthropic.com>
</commit_message>
<xml_diff>
--- a/presentation/AgentPulse_Project_Deck.pptx
+++ b/presentation/AgentPulse_Project_Deck.pptx
@@ -11036,7 +11036,7 @@
                           <a:ea typeface="Calibri" pitchFamily="34" charset="-122"/>
                           <a:cs typeface="Calibri" pitchFamily="34" charset="-120"/>
                         </a:rPr>
-                        <a:t>1 error, in dead code</a:t>
+                        <a:t>clean</a:t>
                       </a:r>
                       <a:endParaRPr lang="en-US" sz="1250" dirty="0">
                         <a:latin typeface="Calibri" charset="0"/>
@@ -13622,7 +13622,7 @@
                   <a:srgbClr val="14171F"/>
                 </a:solidFill>
               </a:rPr>
-              <a:t>Extend dashboard tests from the mapping layer to the components, and remove the APM tab that is reachable from the dock and the command palette but renders nothing.</a:t>
+              <a:t>Extend dashboard tests from the mapping layer to the components. The 32 tests cover adapters.ts and api.ts; none of the 33 components has one.</a:t>
             </a:r>
             <a:endParaRPr lang="en-US" sz="1500" dirty="0"/>
           </a:p>

</xml_diff>